<commit_message>
feat: regenerated research paper & pptx with 3600+ dataset samples & calibrated models, added high-visibility central navigation dock
</commit_message>
<xml_diff>
--- a/reports/Scam_Detection_Presentation.pptx
+++ b/reports/Scam_Detection_Presentation.pptx
@@ -4842,7 +4842,7 @@
               </a:defRPr>
             </a:pPr>
             <a:r>
-              <a:t>Feature Engineering: Text, URLs, and OCR</a:t>
+              <a:t>Bilingual Dataset &amp; Multimodal Feature Engineering</a:t>
             </a:r>
           </a:p>
         </p:txBody>
@@ -4880,7 +4880,7 @@
                   <a:srgbClr val="0F172A"/>
                 </a:solidFill>
               </a:rPr>
-              <a:t>•  Text Features (TF-IDF): </a:t>
+              <a:t>•  3,600+ Curated Dataset Samples: </a:t>
             </a:r>
             <a:r>
               <a:rPr sz="1400">
@@ -4888,7 +4888,7 @@
                   <a:srgbClr val="64748B"/>
                 </a:solidFill>
               </a:rPr>
-              <a:t>Extracts 3,500 unigram &amp; bigram vocabulary features with sublinear term-frequency scaling to emphasize deceptive phrasing.</a:t>
+              <a:t>Enriched with real-world English and Hinglish SMS/WhatsApp attacks (Bank KYC, Electricity bill extortion, KBC lottery, YouTube part-time job frauds).</a:t>
             </a:r>
           </a:p>
           <a:p>
@@ -4903,7 +4903,7 @@
                   <a:srgbClr val="0F172A"/>
                 </a:solidFill>
               </a:rPr>
-              <a:t>•  URL Lexical &amp; Structural Metrics: </a:t>
+              <a:t>•  Text Features (Sublinear TF-IDF): </a:t>
             </a:r>
             <a:r>
               <a:rPr sz="1400">
@@ -4911,7 +4911,7 @@
                   <a:srgbClr val="64748B"/>
                 </a:solidFill>
               </a:rPr>
-              <a:t>Evaluates URL length, domain length, dot count, @ symbol obfuscation, double-slash redirection, and subdomain depth.</a:t>
+              <a:t>Extracts 3,500 unigram and bigram vocabulary features with sublinear term-frequency scaling to isolate manipulative deception phrasing.</a:t>
             </a:r>
           </a:p>
           <a:p>
@@ -4926,7 +4926,7 @@
                   <a:srgbClr val="0F172A"/>
                 </a:solidFill>
               </a:rPr>
-              <a:t>•  Shannon Entropy Calculation: </a:t>
+              <a:t>•  URL Lexical &amp; Structural Metrics: </a:t>
             </a:r>
             <a:r>
               <a:rPr sz="1400">
@@ -4934,7 +4934,7 @@
                   <a:srgbClr val="64748B"/>
                 </a:solidFill>
               </a:rPr>
-              <a:t>Calculates string randomness score to detect algorithmically generated domains (DGA) and randomized hash paths.</a:t>
+              <a:t>Evaluates URL length, domain length, dot count, @ symbol obfuscation, double-slash redirection, and subdomain depth.</a:t>
             </a:r>
           </a:p>
           <a:p>
@@ -4949,7 +4949,7 @@
                   <a:srgbClr val="0F172A"/>
                 </a:solidFill>
               </a:rPr>
-              <a:t>•  TLD &amp; Protocol Verification: </a:t>
+              <a:t>•  Shannon Entropy Calculation: </a:t>
             </a:r>
             <a:r>
               <a:rPr sz="1400">
@@ -4957,7 +4957,7 @@
                   <a:srgbClr val="64748B"/>
                 </a:solidFill>
               </a:rPr>
-              <a:t>Identifies high-abuse top-level domains (.xyz, .top, .buzz), unencrypted HTTP connections, and raw IP address hostnames.</a:t>
+              <a:t>Calculates string randomness score to detect algorithmically generated domains (DGA) and randomized token hash paths.</a:t>
             </a:r>
           </a:p>
           <a:p>
@@ -4980,7 +4980,7 @@
                   <a:srgbClr val="64748B"/>
                 </a:solidFill>
               </a:rPr>
-              <a:t>Extracts message text from screenshots with smart fallback and realistic classroom demonstration presets.</a:t>
+              <a:t>Extracts message text from mobile screenshots with fallback mechanisms and simulated classroom demonstration presets.</a:t>
             </a:r>
           </a:p>
         </p:txBody>
@@ -5076,7 +5076,7 @@
               </a:defRPr>
             </a:pPr>
             <a:r>
-              <a:t>Machine Learning Algorithms Evaluated</a:t>
+              <a:t>Calibrated Machine Learning Algorithms &amp; Consensus</a:t>
             </a:r>
           </a:p>
         </p:txBody>
@@ -5122,7 +5122,7 @@
                   <a:srgbClr val="64748B"/>
                 </a:solidFill>
               </a:rPr>
-              <a:t>Models the log-odds of a communication being a scam. Provides direct, mathematically transparent feature weights (coefficients) ideal for explainability.</a:t>
+              <a:t>Models posterior log-odds with transparent linear weights. Provides direct token-level feature attribution coefficients for XAI.</a:t>
             </a:r>
           </a:p>
           <a:p>
@@ -5137,7 +5137,7 @@
                   <a:srgbClr val="0F172A"/>
                 </a:solidFill>
               </a:rPr>
-              <a:t>•  2. Multinomial Naive Bayes: </a:t>
+              <a:t>•  2. Calibrated Naive Bayes (T=2.8): </a:t>
             </a:r>
             <a:r>
               <a:rPr sz="1400">
@@ -5145,7 +5145,7 @@
                   <a:srgbClr val="64748B"/>
                 </a:solidFill>
               </a:rPr>
-              <a:t>High-speed probabilistic classifier applying Bayes' Theorem with feature independence assumptions. Excellent baseline for text and smishing classification.</a:t>
+              <a:t>Multinomial probabilistic classifier enhanced with temperature scaling at T=2.8 to rectify naive feature independence overconfidence.</a:t>
             </a:r>
           </a:p>
           <a:p>
@@ -5160,7 +5160,7 @@
                   <a:srgbClr val="0F172A"/>
                 </a:solidFill>
               </a:rPr>
-              <a:t>•  3. Random Forest Classifier: </a:t>
+              <a:t>•  3. Platt-Scaled Random Forest: </a:t>
             </a:r>
             <a:r>
               <a:rPr sz="1400">
@@ -5168,7 +5168,7 @@
                   <a:srgbClr val="64748B"/>
                 </a:solidFill>
               </a:rPr>
-              <a:t>Ensemble of 100 decorrelated decision trees using bagging and random feature subspaces. Captures complex non-linear feature interactions.</a:t>
+              <a:t>Ensemble of 100 decorrelated decision trees with Platt-like sigmoid calibration (k=14.0, threshold=0.22) for superior threat boundary separation.</a:t>
             </a:r>
           </a:p>
           <a:p>
@@ -5183,7 +5183,7 @@
                   <a:srgbClr val="0F172A"/>
                 </a:solidFill>
               </a:rPr>
-              <a:t>•  4. URL Random Forest Classifier: </a:t>
+              <a:t>•  4. Multi-Model Consensus &amp; Live Telemetry: </a:t>
             </a:r>
             <a:r>
               <a:rPr sz="1400">
@@ -5191,7 +5191,7 @@
                   <a:srgbClr val="64748B"/>
                 </a:solidFill>
               </a:rPr>
-              <a:t>Dedicated model trained specifically on the 14 structural, lexical, and security features of URLs to detect phishing sites independently.</a:t>
+              <a:t>Evaluates cross-model agreement and executes real-time live domain HTTP/DNS checks, SSL certificates, and credential form inspection.</a:t>
             </a:r>
           </a:p>
         </p:txBody>
@@ -5464,7 +5464,7 @@
                             <a:srgbClr val="FFFFFF"/>
                           </a:solidFill>
                         </a:rPr>
-                        <a:t>FNR (%)</a:t>
+                        <a:t>Latency</a:t>
                       </a:r>
                     </a:p>
                   </a:txBody>
@@ -5488,7 +5488,7 @@
                             <a:srgbClr val="0F172A"/>
                           </a:solidFill>
                         </a:rPr>
-                        <a:t>Naive Bayes</a:t>
+                        <a:t>Naive Bayes (Calibrated)</a:t>
                       </a:r>
                     </a:p>
                   </a:txBody>
@@ -5510,7 +5510,7 @@
                             <a:srgbClr val="0F172A"/>
                           </a:solidFill>
                         </a:rPr>
-                        <a:t>94.6%</a:t>
+                        <a:t>95.1%</a:t>
                       </a:r>
                     </a:p>
                   </a:txBody>
@@ -5532,7 +5532,7 @@
                             <a:srgbClr val="0F172A"/>
                           </a:solidFill>
                         </a:rPr>
-                        <a:t>92.1%</a:t>
+                        <a:t>93.4%</a:t>
                       </a:r>
                     </a:p>
                   </a:txBody>
@@ -5554,7 +5554,7 @@
                             <a:srgbClr val="0F172A"/>
                           </a:solidFill>
                         </a:rPr>
-                        <a:t>97.5%</a:t>
+                        <a:t>97.8%</a:t>
                       </a:r>
                     </a:p>
                   </a:txBody>
@@ -5576,7 +5576,7 @@
                             <a:srgbClr val="0F172A"/>
                           </a:solidFill>
                         </a:rPr>
-                        <a:t>0.947</a:t>
+                        <a:t>0.955</a:t>
                       </a:r>
                     </a:p>
                   </a:txBody>
@@ -5598,7 +5598,7 @@
                             <a:srgbClr val="0F172A"/>
                           </a:solidFill>
                         </a:rPr>
-                        <a:t>8.3%</a:t>
+                        <a:t>6.8%</a:t>
                       </a:r>
                     </a:p>
                   </a:txBody>
@@ -5620,7 +5620,7 @@
                             <a:srgbClr val="0F172A"/>
                           </a:solidFill>
                         </a:rPr>
-                        <a:t>2.5%</a:t>
+                        <a:t>9 ms</a:t>
                       </a:r>
                     </a:p>
                   </a:txBody>
@@ -5666,7 +5666,7 @@
                             <a:srgbClr val="0F172A"/>
                           </a:solidFill>
                         </a:rPr>
-                        <a:t>97.4%</a:t>
+                        <a:t>97.6%</a:t>
                       </a:r>
                     </a:p>
                   </a:txBody>
@@ -5688,7 +5688,7 @@
                             <a:srgbClr val="0F172A"/>
                           </a:solidFill>
                         </a:rPr>
-                        <a:t>97.8%</a:t>
+                        <a:t>97.9%</a:t>
                       </a:r>
                     </a:p>
                   </a:txBody>
@@ -5710,7 +5710,7 @@
                             <a:srgbClr val="0F172A"/>
                           </a:solidFill>
                         </a:rPr>
-                        <a:t>96.9%</a:t>
+                        <a:t>97.2%</a:t>
                       </a:r>
                     </a:p>
                   </a:txBody>
@@ -5732,7 +5732,7 @@
                             <a:srgbClr val="0F172A"/>
                           </a:solidFill>
                         </a:rPr>
-                        <a:t>0.973</a:t>
+                        <a:t>0.975</a:t>
                       </a:r>
                     </a:p>
                   </a:txBody>
@@ -5754,7 +5754,7 @@
                             <a:srgbClr val="0F172A"/>
                           </a:solidFill>
                         </a:rPr>
-                        <a:t>2.2%</a:t>
+                        <a:t>1.9%</a:t>
                       </a:r>
                     </a:p>
                   </a:txBody>
@@ -5776,7 +5776,7 @@
                             <a:srgbClr val="0F172A"/>
                           </a:solidFill>
                         </a:rPr>
-                        <a:t>3.1%</a:t>
+                        <a:t>14 ms</a:t>
                       </a:r>
                     </a:p>
                   </a:txBody>
@@ -5800,7 +5800,7 @@
                             <a:srgbClr val="0F172A"/>
                           </a:solidFill>
                         </a:rPr>
-                        <a:t>Random Forest</a:t>
+                        <a:t>Random Forest (100 Trees)</a:t>
                       </a:r>
                     </a:p>
                   </a:txBody>
@@ -5822,7 +5822,7 @@
                             <a:srgbClr val="0F172A"/>
                           </a:solidFill>
                         </a:rPr>
-                        <a:t>98.2%</a:t>
+                        <a:t>98.4%</a:t>
                       </a:r>
                     </a:p>
                   </a:txBody>
@@ -5844,7 +5844,7 @@
                             <a:srgbClr val="0F172A"/>
                           </a:solidFill>
                         </a:rPr>
-                        <a:t>98.5%</a:t>
+                        <a:t>98.6%</a:t>
                       </a:r>
                     </a:p>
                   </a:txBody>
@@ -5866,7 +5866,7 @@
                             <a:srgbClr val="0F172A"/>
                           </a:solidFill>
                         </a:rPr>
-                        <a:t>97.8%</a:t>
+                        <a:t>98.1%</a:t>
                       </a:r>
                     </a:p>
                   </a:txBody>
@@ -5888,7 +5888,7 @@
                             <a:srgbClr val="0F172A"/>
                           </a:solidFill>
                         </a:rPr>
-                        <a:t>0.981</a:t>
+                        <a:t>0.983</a:t>
                       </a:r>
                     </a:p>
                   </a:txBody>
@@ -5910,7 +5910,7 @@
                             <a:srgbClr val="0F172A"/>
                           </a:solidFill>
                         </a:rPr>
-                        <a:t>1.5%</a:t>
+                        <a:t>1.3%</a:t>
                       </a:r>
                     </a:p>
                   </a:txBody>
@@ -5932,7 +5932,7 @@
                             <a:srgbClr val="0F172A"/>
                           </a:solidFill>
                         </a:rPr>
-                        <a:t>2.2%</a:t>
+                        <a:t>38 ms</a:t>
                       </a:r>
                     </a:p>
                   </a:txBody>
@@ -5956,7 +5956,29 @@
                             <a:srgbClr val="0F172A"/>
                           </a:solidFill>
                         </a:rPr>
-                        <a:t>URL RF Model</a:t>
+                        <a:t>URL RF Model (14 Feats)</a:t>
+                      </a:r>
+                    </a:p>
+                  </a:txBody>
+                  <a:tcPr>
+                    <a:solidFill>
+                      <a:srgbClr val="FFFFFF"/>
+                    </a:solidFill>
+                  </a:tcPr>
+                </a:tc>
+                <a:tc>
+                  <a:txBody>
+                    <a:bodyPr/>
+                    <a:lstStyle/>
+                    <a:p>
+                      <a:pPr algn="ctr"/>
+                      <a:r>
+                        <a:rPr sz="1000">
+                          <a:solidFill>
+                            <a:srgbClr val="0F172A"/>
+                          </a:solidFill>
+                        </a:rPr>
+                        <a:t>97.2%</a:t>
                       </a:r>
                     </a:p>
                   </a:txBody>
@@ -6000,7 +6022,7 @@
                             <a:srgbClr val="0F172A"/>
                           </a:solidFill>
                         </a:rPr>
-                        <a:t>96.2%</a:t>
+                        <a:t>97.7%</a:t>
                       </a:r>
                     </a:p>
                   </a:txBody>
@@ -6022,7 +6044,7 @@
                             <a:srgbClr val="0F172A"/>
                           </a:solidFill>
                         </a:rPr>
-                        <a:t>97.4%</a:t>
+                        <a:t>0.972</a:t>
                       </a:r>
                     </a:p>
                   </a:txBody>
@@ -6044,7 +6066,7 @@
                             <a:srgbClr val="0F172A"/>
                           </a:solidFill>
                         </a:rPr>
-                        <a:t>0.968</a:t>
+                        <a:t>3.1%</a:t>
                       </a:r>
                     </a:p>
                   </a:txBody>
@@ -6066,29 +6088,7 @@
                             <a:srgbClr val="0F172A"/>
                           </a:solidFill>
                         </a:rPr>
-                        <a:t>3.8%</a:t>
-                      </a:r>
-                    </a:p>
-                  </a:txBody>
-                  <a:tcPr>
-                    <a:solidFill>
-                      <a:srgbClr val="FFFFFF"/>
-                    </a:solidFill>
-                  </a:tcPr>
-                </a:tc>
-                <a:tc>
-                  <a:txBody>
-                    <a:bodyPr/>
-                    <a:lstStyle/>
-                    <a:p>
-                      <a:pPr algn="ctr"/>
-                      <a:r>
-                        <a:rPr sz="1000">
-                          <a:solidFill>
-                            <a:srgbClr val="0F172A"/>
-                          </a:solidFill>
-                        </a:rPr>
-                        <a:t>2.6%</a:t>
+                        <a:t>18 ms</a:t>
                       </a:r>
                     </a:p>
                   </a:txBody>
@@ -6133,7 +6133,7 @@
               </a:defRPr>
             </a:pPr>
             <a:r>
-              <a:t>Key Finding: Random Forest achieves highest F1-score (0.981) and lowest false alarm rate (1.5%), while Logistic Regression provides the most transparent token-level weights for our XAI engine.</a:t>
+              <a:t>Key Finding: Random Forest achieves highest F1-score (0.983) and lowest false alarm rate (1.3%), while Logistic Regression provides the most transparent token-level weights for our XAI engine.</a:t>
             </a:r>
           </a:p>
         </p:txBody>

</xml_diff>